<commit_message>
fix switch hybrid, update results and reports
</commit_message>
<xml_diff>
--- a/report/Υβριδικό Σύστημα Συστάσεων Ταινιών.pptx
+++ b/report/Υβριδικό Σύστημα Συστάσεων Ταινιών.pptx
@@ -2752,6 +2752,13 @@
           </a:gradFill>
           <a:ln/>
         </p:spPr>
+        <p:txBody>
+          <a:bodyPr/>
+          <a:lstStyle/>
+          <a:p>
+            <a:endParaRPr/>
+          </a:p>
+        </p:txBody>
       </p:sp>
       <p:sp>
         <p:nvSpPr>
@@ -2785,6 +2792,13 @@
           </a:gradFill>
           <a:ln/>
         </p:spPr>
+        <p:txBody>
+          <a:bodyPr/>
+          <a:lstStyle/>
+          <a:p>
+            <a:endParaRPr/>
+          </a:p>
+        </p:txBody>
       </p:sp>
       <p:sp>
         <p:nvSpPr>
@@ -2889,6 +2903,13 @@
           </a:solidFill>
           <a:ln/>
         </p:spPr>
+        <p:txBody>
+          <a:bodyPr/>
+          <a:lstStyle/>
+          <a:p>
+            <a:endParaRPr/>
+          </a:p>
+        </p:txBody>
       </p:sp>
       <p:sp>
         <p:nvSpPr>
@@ -2916,8 +2937,16 @@
                 <a:spcPct val="100000"/>
               </a:lnSpc>
             </a:pPr>
-            <a:r>
-              <a:rPr lang="en-US" sz="1600" dirty="0">
+            <a:endParaRPr lang="en-US" sz="1600" dirty="0"/>
+          </a:p>
+          <a:p>
+            <a:pPr algn="ctr">
+              <a:lnSpc>
+                <a:spcPct val="100000"/>
+              </a:lnSpc>
+            </a:pPr>
+            <a:r>
+              <a:rPr lang="el-GR" sz="1600" dirty="0">
                 <a:solidFill>
                   <a:srgbClr val="6B9CBF"/>
                 </a:solidFill>
@@ -2925,7 +2954,55 @@
                 <a:ea typeface="Liter" pitchFamily="34" charset="-122"/>
                 <a:cs typeface="Liter" pitchFamily="34" charset="-120"/>
               </a:rPr>
-              <a:t>Ακαδημαϊκό Έτος 2025–2026</a:t>
+              <a:t>Γκάρο Αριστοτέλης</a:t>
+            </a:r>
+            <a:r>
+              <a:rPr lang="en-US" sz="1600">
+                <a:solidFill>
+                  <a:srgbClr val="6B9CBF"/>
+                </a:solidFill>
+                <a:latin typeface="Liter" pitchFamily="34" charset="0"/>
+                <a:ea typeface="Liter" pitchFamily="34" charset="-122"/>
+                <a:cs typeface="Liter" pitchFamily="34" charset="-120"/>
+              </a:rPr>
+              <a:t> – mtn2503</a:t>
+            </a:r>
+            <a:endParaRPr lang="en-US" sz="1600" dirty="0">
+              <a:solidFill>
+                <a:srgbClr val="6B9CBF"/>
+              </a:solidFill>
+              <a:latin typeface="Liter" pitchFamily="34" charset="0"/>
+              <a:ea typeface="Liter" pitchFamily="34" charset="-122"/>
+              <a:cs typeface="Liter" pitchFamily="34" charset="-120"/>
+            </a:endParaRPr>
+          </a:p>
+          <a:p>
+            <a:pPr algn="ctr">
+              <a:lnSpc>
+                <a:spcPct val="100000"/>
+              </a:lnSpc>
+            </a:pPr>
+            <a:r>
+              <a:rPr lang="en-US" sz="1600" dirty="0" err="1">
+                <a:solidFill>
+                  <a:srgbClr val="6B9CBF"/>
+                </a:solidFill>
+                <a:latin typeface="Liter" pitchFamily="34" charset="0"/>
+                <a:ea typeface="Liter" pitchFamily="34" charset="-122"/>
+                <a:cs typeface="Liter" pitchFamily="34" charset="-120"/>
+              </a:rPr>
+              <a:t>Ακ</a:t>
+            </a:r>
+            <a:r>
+              <a:rPr lang="en-US" sz="1600" dirty="0">
+                <a:solidFill>
+                  <a:srgbClr val="6B9CBF"/>
+                </a:solidFill>
+                <a:latin typeface="Liter" pitchFamily="34" charset="0"/>
+                <a:ea typeface="Liter" pitchFamily="34" charset="-122"/>
+                <a:cs typeface="Liter" pitchFamily="34" charset="-120"/>
+              </a:rPr>
+              <a:t>αδημαϊκό Έτος 2025–2026</a:t>
             </a:r>
             <a:endParaRPr lang="en-US" sz="1600" dirty="0"/>
           </a:p>
@@ -3027,6 +3104,13 @@
           </a:solidFill>
           <a:ln/>
         </p:spPr>
+        <p:txBody>
+          <a:bodyPr/>
+          <a:lstStyle/>
+          <a:p>
+            <a:endParaRPr/>
+          </a:p>
+        </p:txBody>
       </p:sp>
       <p:sp>
         <p:nvSpPr>
@@ -3054,6 +3138,13 @@
             <a:prstDash val="solid"/>
           </a:ln>
         </p:spPr>
+        <p:txBody>
+          <a:bodyPr/>
+          <a:lstStyle/>
+          <a:p>
+            <a:endParaRPr/>
+          </a:p>
+        </p:txBody>
       </p:sp>
       <p:sp>
         <p:nvSpPr>
@@ -3263,6 +3354,13 @@
           </a:solidFill>
           <a:ln/>
         </p:spPr>
+        <p:txBody>
+          <a:bodyPr/>
+          <a:lstStyle/>
+          <a:p>
+            <a:endParaRPr/>
+          </a:p>
+        </p:txBody>
       </p:sp>
       <p:sp>
         <p:nvSpPr>
@@ -3506,6 +3604,13 @@
             <a:prstDash val="solid"/>
           </a:ln>
         </p:spPr>
+        <p:txBody>
+          <a:bodyPr/>
+          <a:lstStyle/>
+          <a:p>
+            <a:endParaRPr/>
+          </a:p>
+        </p:txBody>
       </p:sp>
       <p:sp>
         <p:nvSpPr>
@@ -3533,6 +3638,13 @@
           </a:solidFill>
           <a:ln/>
         </p:spPr>
+        <p:txBody>
+          <a:bodyPr/>
+          <a:lstStyle/>
+          <a:p>
+            <a:endParaRPr/>
+          </a:p>
+        </p:txBody>
       </p:sp>
       <p:sp>
         <p:nvSpPr>
@@ -3781,6 +3893,13 @@
           </a:gradFill>
           <a:ln/>
         </p:spPr>
+        <p:txBody>
+          <a:bodyPr/>
+          <a:lstStyle/>
+          <a:p>
+            <a:endParaRPr/>
+          </a:p>
+        </p:txBody>
       </p:sp>
       <p:sp>
         <p:nvSpPr>
@@ -3951,6 +4070,13 @@
           </a:solidFill>
           <a:ln/>
         </p:spPr>
+        <p:txBody>
+          <a:bodyPr/>
+          <a:lstStyle/>
+          <a:p>
+            <a:endParaRPr/>
+          </a:p>
+        </p:txBody>
       </p:sp>
       <p:sp>
         <p:nvSpPr>
@@ -4259,6 +4385,13 @@
           </a:solidFill>
           <a:ln/>
         </p:spPr>
+        <p:txBody>
+          <a:bodyPr/>
+          <a:lstStyle/>
+          <a:p>
+            <a:endParaRPr/>
+          </a:p>
+        </p:txBody>
       </p:sp>
       <p:sp>
         <p:nvSpPr>
@@ -4279,6 +4412,13 @@
           </a:solidFill>
           <a:ln/>
         </p:spPr>
+        <p:txBody>
+          <a:bodyPr/>
+          <a:lstStyle/>
+          <a:p>
+            <a:endParaRPr/>
+          </a:p>
+        </p:txBody>
       </p:sp>
       <p:sp>
         <p:nvSpPr>
@@ -4446,6 +4586,13 @@
             <a:tailEnd type="arrow"/>
           </a:ln>
         </p:spPr>
+        <p:txBody>
+          <a:bodyPr/>
+          <a:lstStyle/>
+          <a:p>
+            <a:endParaRPr/>
+          </a:p>
+        </p:txBody>
       </p:sp>
       <p:sp>
         <p:nvSpPr>
@@ -4466,6 +4613,13 @@
           </a:solidFill>
           <a:ln/>
         </p:spPr>
+        <p:txBody>
+          <a:bodyPr/>
+          <a:lstStyle/>
+          <a:p>
+            <a:endParaRPr/>
+          </a:p>
+        </p:txBody>
       </p:sp>
       <p:sp>
         <p:nvSpPr>
@@ -4633,6 +4787,13 @@
             <a:tailEnd type="arrow"/>
           </a:ln>
         </p:spPr>
+        <p:txBody>
+          <a:bodyPr/>
+          <a:lstStyle/>
+          <a:p>
+            <a:endParaRPr/>
+          </a:p>
+        </p:txBody>
       </p:sp>
       <p:sp>
         <p:nvSpPr>
@@ -4653,6 +4814,13 @@
           </a:solidFill>
           <a:ln/>
         </p:spPr>
+        <p:txBody>
+          <a:bodyPr/>
+          <a:lstStyle/>
+          <a:p>
+            <a:endParaRPr/>
+          </a:p>
+        </p:txBody>
       </p:sp>
       <p:sp>
         <p:nvSpPr>
@@ -4833,6 +5001,13 @@
             <a:prstDash val="solid"/>
           </a:ln>
         </p:spPr>
+        <p:txBody>
+          <a:bodyPr/>
+          <a:lstStyle/>
+          <a:p>
+            <a:endParaRPr/>
+          </a:p>
+        </p:txBody>
       </p:sp>
       <p:sp>
         <p:nvSpPr>
@@ -4910,62 +5085,29 @@
                 <a:ea typeface="Liter" pitchFamily="34" charset="-122"/>
                 <a:cs typeface="Liter" pitchFamily="34" charset="-120"/>
               </a:rPr>
-              <a:t>• score = CB αν |ratings(u)| &lt; threshold, αλλιώς CF → threshold = </a:t>
-            </a:r>
-            <a:r>
-              <a:rPr lang="en-US" sz="2000" b="1" dirty="0">
-                <a:solidFill>
-                  <a:srgbClr val="FF7F50"/>
+              <a:t>• score = CB αν |ratings(u)| &lt; threshold, αλλιώς CF → threshold = 50</a:t>
+            </a:r>
+            <a:endParaRPr lang="en-US" sz="2000" dirty="0"/>
+          </a:p>
+          <a:p>
+            <a:pPr>
+              <a:lnSpc>
+                <a:spcPct val="160000"/>
+              </a:lnSpc>
+              <a:spcBef>
+                <a:spcPts val="500"/>
+              </a:spcBef>
+            </a:pPr>
+            <a:r>
+              <a:rPr lang="en-US" sz="2000" dirty="0">
+                <a:solidFill>
+                  <a:srgbClr val="3C4A5A"/>
                 </a:solidFill>
                 <a:latin typeface="Liter" pitchFamily="34" charset="0"/>
                 <a:ea typeface="Liter" pitchFamily="34" charset="-122"/>
                 <a:cs typeface="Liter" pitchFamily="34" charset="-120"/>
               </a:rPr>
-              <a:t>5</a:t>
-            </a:r>
-            <a:endParaRPr lang="en-US" sz="2000" dirty="0"/>
-          </a:p>
-          <a:p>
-            <a:pPr>
-              <a:lnSpc>
-                <a:spcPct val="160000"/>
-              </a:lnSpc>
-              <a:spcBef>
-                <a:spcPts val="500"/>
-              </a:spcBef>
-            </a:pPr>
-            <a:r>
-              <a:rPr lang="en-US" sz="2000" dirty="0">
-                <a:solidFill>
-                  <a:srgbClr val="3C4A5A"/>
-                </a:solidFill>
-                <a:latin typeface="Liter" pitchFamily="34" charset="0"/>
-                <a:ea typeface="Liter" pitchFamily="34" charset="-122"/>
-                <a:cs typeface="Liter" pitchFamily="34" charset="-120"/>
-              </a:rPr>
-              <a:t>• Κανένας χρήστης δεν έχει &lt;5 ratings → </a:t>
-            </a:r>
-            <a:r>
-              <a:rPr lang="en-US" sz="2000" b="1" dirty="0">
-                <a:solidFill>
-                  <a:srgbClr val="FF7F50"/>
-                </a:solidFill>
-                <a:latin typeface="Liter" pitchFamily="34" charset="0"/>
-                <a:ea typeface="Liter" pitchFamily="34" charset="-122"/>
-                <a:cs typeface="Liter" pitchFamily="34" charset="-120"/>
-              </a:rPr>
-              <a:t>pure SVD</a:t>
-            </a:r>
-            <a:r>
-              <a:rPr lang="en-US" sz="2000" dirty="0">
-                <a:solidFill>
-                  <a:srgbClr val="3C4A5A"/>
-                </a:solidFill>
-                <a:latin typeface="Liter" pitchFamily="34" charset="0"/>
-                <a:ea typeface="Liter" pitchFamily="34" charset="-122"/>
-                <a:cs typeface="Liter" pitchFamily="34" charset="-120"/>
-              </a:rPr>
-              <a:t> (RMSE=0.8784)</a:t>
+              <a:t>• 36.1% χρήστες (&lt;50 ratings στο train) → CB · 63.9% → CF (RMSE=0.8897)</a:t>
             </a:r>
             <a:endParaRPr lang="en-US" sz="2000" dirty="0"/>
           </a:p>
@@ -5082,6 +5224,13 @@
           </a:gradFill>
           <a:ln/>
         </p:spPr>
+        <p:txBody>
+          <a:bodyPr/>
+          <a:lstStyle/>
+          <a:p>
+            <a:endParaRPr/>
+          </a:p>
+        </p:txBody>
       </p:sp>
       <p:sp>
         <p:nvSpPr>
@@ -5302,6 +5451,13 @@
           </a:solidFill>
           <a:ln/>
         </p:spPr>
+        <p:txBody>
+          <a:bodyPr/>
+          <a:lstStyle/>
+          <a:p>
+            <a:endParaRPr/>
+          </a:p>
+        </p:txBody>
       </p:sp>
       <p:graphicFrame>
         <p:nvGraphicFramePr>
@@ -7769,6 +7925,13 @@
             </a:outerShdw>
           </a:effectLst>
         </p:spPr>
+        <p:txBody>
+          <a:bodyPr/>
+          <a:lstStyle/>
+          <a:p>
+            <a:endParaRPr/>
+          </a:p>
+        </p:txBody>
       </p:sp>
       <p:sp>
         <p:nvSpPr>
@@ -8033,6 +8196,13 @@
           </a:solidFill>
           <a:ln/>
         </p:spPr>
+        <p:txBody>
+          <a:bodyPr/>
+          <a:lstStyle/>
+          <a:p>
+            <a:endParaRPr/>
+          </a:p>
+        </p:txBody>
       </p:sp>
       <p:sp>
         <p:nvSpPr>
@@ -8062,6 +8232,13 @@
             </a:outerShdw>
           </a:effectLst>
         </p:spPr>
+        <p:txBody>
+          <a:bodyPr/>
+          <a:lstStyle/>
+          <a:p>
+            <a:endParaRPr/>
+          </a:p>
+        </p:txBody>
       </p:sp>
       <p:sp>
         <p:nvSpPr>
@@ -8255,6 +8432,13 @@
             </a:outerShdw>
           </a:effectLst>
         </p:spPr>
+        <p:txBody>
+          <a:bodyPr/>
+          <a:lstStyle/>
+          <a:p>
+            <a:endParaRPr/>
+          </a:p>
+        </p:txBody>
       </p:sp>
       <p:sp>
         <p:nvSpPr>
@@ -8451,6 +8635,13 @@
           </a:gradFill>
           <a:ln/>
         </p:spPr>
+        <p:txBody>
+          <a:bodyPr/>
+          <a:lstStyle/>
+          <a:p>
+            <a:endParaRPr/>
+          </a:p>
+        </p:txBody>
       </p:sp>
       <p:sp>
         <p:nvSpPr>
@@ -8646,6 +8837,13 @@
             <a:prstDash val="solid"/>
           </a:ln>
         </p:spPr>
+        <p:txBody>
+          <a:bodyPr/>
+          <a:lstStyle/>
+          <a:p>
+            <a:endParaRPr/>
+          </a:p>
+        </p:txBody>
       </p:sp>
       <p:sp>
         <p:nvSpPr>
@@ -8723,7 +8921,7 @@
                 <a:ea typeface="微软雅黑" pitchFamily="34" charset="-122"/>
                 <a:cs typeface="微软雅黑" pitchFamily="34" charset="-120"/>
               </a:rPr>
-              <a:t>0.8784</a:t>
+              <a:t>0.8897</a:t>
             </a:r>
             <a:endParaRPr lang="en-US" sz="1600" dirty="0"/>
           </a:p>
@@ -8764,7 +8962,7 @@
                 <a:ea typeface="Liter" pitchFamily="34" charset="-122"/>
                 <a:cs typeface="Liter" pitchFamily="34" charset="-120"/>
               </a:rPr>
-              <a:t>RMSE (= pure CF)</a:t>
+              <a:t>RMSE (thr=50)</a:t>
             </a:r>
             <a:endParaRPr lang="en-US" sz="1600" dirty="0"/>
           </a:p>
@@ -8805,7 +9003,7 @@
                 <a:ea typeface="Liter" pitchFamily="34" charset="-122"/>
                 <a:cs typeface="Liter" pitchFamily="34" charset="-120"/>
               </a:rPr>
-              <a:t>F1@10: 0.6618</a:t>
+              <a:t>F1@10: 0.6582</a:t>
             </a:r>
             <a:endParaRPr lang="en-US" sz="1600" dirty="0"/>
           </a:p>
@@ -8837,6 +9035,13 @@
             <a:prstDash val="solid"/>
           </a:ln>
         </p:spPr>
+        <p:txBody>
+          <a:bodyPr/>
+          <a:lstStyle/>
+          <a:p>
+            <a:endParaRPr/>
+          </a:p>
+        </p:txBody>
       </p:sp>
       <p:sp>
         <p:nvSpPr>
@@ -8939,7 +9144,7 @@
                 <a:ea typeface="Liter" pitchFamily="34" charset="-122"/>
                 <a:cs typeface="Liter" pitchFamily="34" charset="-120"/>
               </a:rPr>
-              <a:t>• Switching Hybrid = pure CF (κανένας με &lt;5 ratings)</a:t>
+              <a:t>• Switching Hybrid (thr=50): 36.1% → CB, RMSE=0.8897</a:t>
             </a:r>
             <a:endParaRPr lang="en-US" sz="2000" dirty="0"/>
           </a:p>
@@ -9122,6 +9327,13 @@
           </a:gradFill>
           <a:ln/>
         </p:spPr>
+        <p:txBody>
+          <a:bodyPr/>
+          <a:lstStyle/>
+          <a:p>
+            <a:endParaRPr/>
+          </a:p>
+        </p:txBody>
       </p:sp>
       <p:sp>
         <p:nvSpPr>
@@ -9342,6 +9554,13 @@
           </a:solidFill>
           <a:ln/>
         </p:spPr>
+        <p:txBody>
+          <a:bodyPr/>
+          <a:lstStyle/>
+          <a:p>
+            <a:endParaRPr/>
+          </a:p>
+        </p:txBody>
       </p:sp>
       <p:sp>
         <p:nvSpPr>
@@ -9369,6 +9588,13 @@
             <a:prstDash val="solid"/>
           </a:ln>
         </p:spPr>
+        <p:txBody>
+          <a:bodyPr/>
+          <a:lstStyle/>
+          <a:p>
+            <a:endParaRPr/>
+          </a:p>
+        </p:txBody>
       </p:sp>
       <p:sp>
         <p:nvSpPr>
@@ -9467,6 +9693,13 @@
           </a:solidFill>
           <a:ln/>
         </p:spPr>
+        <p:txBody>
+          <a:bodyPr/>
+          <a:lstStyle/>
+          <a:p>
+            <a:endParaRPr/>
+          </a:p>
+        </p:txBody>
       </p:sp>
       <p:sp>
         <p:nvSpPr>
@@ -9654,7 +9887,7 @@
                 <a:ea typeface="Liter" pitchFamily="34" charset="-122"/>
                 <a:cs typeface="Liter" pitchFamily="34" charset="-120"/>
               </a:rPr>
-              <a:t>• Switching = pure CF</a:t>
+              <a:t>• Switching thr=50, RMSE=0.8897</a:t>
             </a:r>
             <a:endParaRPr lang="en-US" sz="2000" dirty="0"/>
           </a:p>
@@ -9686,6 +9919,13 @@
             <a:prstDash val="solid"/>
           </a:ln>
         </p:spPr>
+        <p:txBody>
+          <a:bodyPr/>
+          <a:lstStyle/>
+          <a:p>
+            <a:endParaRPr/>
+          </a:p>
+        </p:txBody>
       </p:sp>
       <p:sp>
         <p:nvSpPr>
@@ -9821,6 +10061,13 @@
           </a:solidFill>
           <a:ln/>
         </p:spPr>
+        <p:txBody>
+          <a:bodyPr/>
+          <a:lstStyle/>
+          <a:p>
+            <a:endParaRPr/>
+          </a:p>
+        </p:txBody>
       </p:sp>
       <p:sp>
         <p:nvSpPr>
@@ -9920,7 +10167,7 @@
                 <a:ea typeface="Liter" pitchFamily="34" charset="-122"/>
                 <a:cs typeface="Liter" pitchFamily="34" charset="-120"/>
               </a:rPr>
-              <a:t>• Καμία cold-start αξιολόγηση</a:t>
+              <a:t>• Περιορισμένη cold-start αξιολόγηση</a:t>
             </a:r>
             <a:endParaRPr lang="en-US" sz="2000" dirty="0"/>
           </a:p>
@@ -10012,6 +10259,13 @@
           </a:gradFill>
           <a:ln/>
         </p:spPr>
+        <p:txBody>
+          <a:bodyPr/>
+          <a:lstStyle/>
+          <a:p>
+            <a:endParaRPr/>
+          </a:p>
+        </p:txBody>
       </p:sp>
       <p:sp>
         <p:nvSpPr>
@@ -10129,6 +10383,13 @@
           </a:solidFill>
           <a:ln/>
         </p:spPr>
+        <p:txBody>
+          <a:bodyPr/>
+          <a:lstStyle/>
+          <a:p>
+            <a:endParaRPr/>
+          </a:p>
+        </p:txBody>
       </p:sp>
       <p:sp>
         <p:nvSpPr>
@@ -10419,6 +10680,13 @@
           </a:gradFill>
           <a:ln/>
         </p:spPr>
+        <p:txBody>
+          <a:bodyPr/>
+          <a:lstStyle/>
+          <a:p>
+            <a:endParaRPr/>
+          </a:p>
+        </p:txBody>
       </p:sp>
       <p:sp>
         <p:nvSpPr>
@@ -10449,6 +10717,13 @@
           </a:gradFill>
           <a:ln/>
         </p:spPr>
+        <p:txBody>
+          <a:bodyPr/>
+          <a:lstStyle/>
+          <a:p>
+            <a:endParaRPr/>
+          </a:p>
+        </p:txBody>
       </p:sp>
       <p:sp>
         <p:nvSpPr>
@@ -10560,6 +10835,14 @@
                 <a:spcPct val="180000"/>
               </a:lnSpc>
             </a:pPr>
+            <a:endParaRPr lang="en-US" sz="1600" dirty="0"/>
+          </a:p>
+          <a:p>
+            <a:pPr algn="ctr">
+              <a:lnSpc>
+                <a:spcPct val="180000"/>
+              </a:lnSpc>
+            </a:pPr>
             <a:r>
               <a:rPr lang="en-US" sz="1800" dirty="0">
                 <a:solidFill>
@@ -10582,7 +10865,7 @@
               </a:lnSpc>
             </a:pPr>
             <a:r>
-              <a:rPr lang="en-US" sz="1800" dirty="0">
+              <a:rPr lang="el-GR" dirty="0">
                 <a:solidFill>
                   <a:srgbClr val="FFFFFF">
                     <a:alpha val="66667"/>
@@ -10592,7 +10875,58 @@
                 <a:ea typeface="微软雅黑" pitchFamily="34" charset="-122"/>
                 <a:cs typeface="微软雅黑" pitchFamily="34" charset="-120"/>
               </a:rPr>
-              <a:t>Ακαδημαϊκό Έτος 2025–2026</a:t>
+              <a:t>Γκάρο Αριστοτέλης – </a:t>
+            </a:r>
+            <a:r>
+              <a:rPr lang="en-US" dirty="0">
+                <a:solidFill>
+                  <a:srgbClr val="FFFFFF">
+                    <a:alpha val="66667"/>
+                  </a:srgbClr>
+                </a:solidFill>
+                <a:latin typeface="微软雅黑" pitchFamily="34" charset="0"/>
+                <a:ea typeface="微软雅黑" pitchFamily="34" charset="-122"/>
+                <a:cs typeface="微软雅黑" pitchFamily="34" charset="-120"/>
+              </a:rPr>
+              <a:t>mtn2503</a:t>
+            </a:r>
+            <a:br>
+              <a:rPr lang="en-US" sz="1800" dirty="0">
+                <a:solidFill>
+                  <a:srgbClr val="FFFFFF">
+                    <a:alpha val="66667"/>
+                  </a:srgbClr>
+                </a:solidFill>
+                <a:latin typeface="微软雅黑" pitchFamily="34" charset="0"/>
+                <a:ea typeface="微软雅黑" pitchFamily="34" charset="-122"/>
+                <a:cs typeface="微软雅黑" pitchFamily="34" charset="-120"/>
+              </a:rPr>
+            </a:br>
+            <a:r>
+              <a:rPr lang="en-US" sz="1800" dirty="0" err="1">
+                <a:solidFill>
+                  <a:srgbClr val="FFFFFF">
+                    <a:alpha val="66667"/>
+                  </a:srgbClr>
+                </a:solidFill>
+                <a:latin typeface="微软雅黑" pitchFamily="34" charset="0"/>
+                <a:ea typeface="微软雅黑" pitchFamily="34" charset="-122"/>
+                <a:cs typeface="微软雅黑" pitchFamily="34" charset="-120"/>
+              </a:rPr>
+              <a:t>Ακ</a:t>
+            </a:r>
+            <a:r>
+              <a:rPr lang="en-US" sz="1800" dirty="0">
+                <a:solidFill>
+                  <a:srgbClr val="FFFFFF">
+                    <a:alpha val="66667"/>
+                  </a:srgbClr>
+                </a:solidFill>
+                <a:latin typeface="微软雅黑" pitchFamily="34" charset="0"/>
+                <a:ea typeface="微软雅黑" pitchFamily="34" charset="-122"/>
+                <a:cs typeface="微软雅黑" pitchFamily="34" charset="-120"/>
+              </a:rPr>
+              <a:t>αδημαϊκό Έτος 2025–2026</a:t>
             </a:r>
             <a:endParaRPr lang="en-US" sz="1600" dirty="0"/>
           </a:p>
@@ -10709,6 +11043,13 @@
           </a:gradFill>
           <a:ln/>
         </p:spPr>
+        <p:txBody>
+          <a:bodyPr/>
+          <a:lstStyle/>
+          <a:p>
+            <a:endParaRPr/>
+          </a:p>
+        </p:txBody>
       </p:sp>
       <p:sp>
         <p:nvSpPr>
@@ -10729,6 +11070,13 @@
           </a:solidFill>
           <a:ln/>
         </p:spPr>
+        <p:txBody>
+          <a:bodyPr/>
+          <a:lstStyle/>
+          <a:p>
+            <a:endParaRPr/>
+          </a:p>
+        </p:txBody>
       </p:sp>
       <p:sp>
         <p:nvSpPr>
@@ -10831,6 +11179,13 @@
           </a:solidFill>
           <a:ln/>
         </p:spPr>
+        <p:txBody>
+          <a:bodyPr/>
+          <a:lstStyle/>
+          <a:p>
+            <a:endParaRPr/>
+          </a:p>
+        </p:txBody>
       </p:sp>
       <p:sp>
         <p:nvSpPr>
@@ -10933,6 +11288,13 @@
           </a:solidFill>
           <a:ln/>
         </p:spPr>
+        <p:txBody>
+          <a:bodyPr/>
+          <a:lstStyle/>
+          <a:p>
+            <a:endParaRPr/>
+          </a:p>
+        </p:txBody>
       </p:sp>
       <p:sp>
         <p:nvSpPr>
@@ -11035,6 +11397,13 @@
           </a:solidFill>
           <a:ln/>
         </p:spPr>
+        <p:txBody>
+          <a:bodyPr/>
+          <a:lstStyle/>
+          <a:p>
+            <a:endParaRPr/>
+          </a:p>
+        </p:txBody>
       </p:sp>
       <p:sp>
         <p:nvSpPr>
@@ -11137,6 +11506,13 @@
           </a:solidFill>
           <a:ln/>
         </p:spPr>
+        <p:txBody>
+          <a:bodyPr/>
+          <a:lstStyle/>
+          <a:p>
+            <a:endParaRPr/>
+          </a:p>
+        </p:txBody>
       </p:sp>
       <p:sp>
         <p:nvSpPr>
@@ -11331,6 +11707,13 @@
           </a:gradFill>
           <a:ln/>
         </p:spPr>
+        <p:txBody>
+          <a:bodyPr/>
+          <a:lstStyle/>
+          <a:p>
+            <a:endParaRPr/>
+          </a:p>
+        </p:txBody>
       </p:sp>
       <p:sp>
         <p:nvSpPr>
@@ -11551,6 +11934,13 @@
           </a:solidFill>
           <a:ln/>
         </p:spPr>
+        <p:txBody>
+          <a:bodyPr/>
+          <a:lstStyle/>
+          <a:p>
+            <a:endParaRPr/>
+          </a:p>
+        </p:txBody>
       </p:sp>
       <p:sp>
         <p:nvSpPr>
@@ -11578,6 +11968,13 @@
             <a:prstDash val="solid"/>
           </a:ln>
         </p:spPr>
+        <p:txBody>
+          <a:bodyPr/>
+          <a:lstStyle/>
+          <a:p>
+            <a:endParaRPr/>
+          </a:p>
+        </p:txBody>
       </p:sp>
       <p:sp>
         <p:nvSpPr>
@@ -11726,6 +12123,13 @@
           </a:solidFill>
           <a:ln/>
         </p:spPr>
+        <p:txBody>
+          <a:bodyPr/>
+          <a:lstStyle/>
+          <a:p>
+            <a:endParaRPr/>
+          </a:p>
+        </p:txBody>
       </p:sp>
       <p:sp>
         <p:nvSpPr>
@@ -11890,6 +12294,13 @@
             <a:prstDash val="solid"/>
           </a:ln>
         </p:spPr>
+        <p:txBody>
+          <a:bodyPr/>
+          <a:lstStyle/>
+          <a:p>
+            <a:endParaRPr/>
+          </a:p>
+        </p:txBody>
       </p:sp>
       <p:sp>
         <p:nvSpPr>
@@ -12246,6 +12657,13 @@
           </a:solidFill>
           <a:ln/>
         </p:spPr>
+        <p:txBody>
+          <a:bodyPr/>
+          <a:lstStyle/>
+          <a:p>
+            <a:endParaRPr/>
+          </a:p>
+        </p:txBody>
       </p:sp>
       <p:sp>
         <p:nvSpPr>
@@ -12404,6 +12822,13 @@
           </a:gradFill>
           <a:ln/>
         </p:spPr>
+        <p:txBody>
+          <a:bodyPr/>
+          <a:lstStyle/>
+          <a:p>
+            <a:endParaRPr/>
+          </a:p>
+        </p:txBody>
       </p:sp>
       <p:sp>
         <p:nvSpPr>
@@ -12542,6 +12967,13 @@
           </a:solidFill>
           <a:ln/>
         </p:spPr>
+        <p:txBody>
+          <a:bodyPr/>
+          <a:lstStyle/>
+          <a:p>
+            <a:endParaRPr/>
+          </a:p>
+        </p:txBody>
       </p:sp>
       <p:sp>
         <p:nvSpPr>
@@ -12802,6 +13234,13 @@
           </a:gradFill>
           <a:ln/>
         </p:spPr>
+        <p:txBody>
+          <a:bodyPr/>
+          <a:lstStyle/>
+          <a:p>
+            <a:endParaRPr/>
+          </a:p>
+        </p:txBody>
       </p:sp>
       <p:sp>
         <p:nvSpPr>
@@ -13022,6 +13461,13 @@
           </a:solidFill>
           <a:ln/>
         </p:spPr>
+        <p:txBody>
+          <a:bodyPr/>
+          <a:lstStyle/>
+          <a:p>
+            <a:endParaRPr/>
+          </a:p>
+        </p:txBody>
       </p:sp>
       <p:sp>
         <p:nvSpPr>
@@ -13051,6 +13497,13 @@
             </a:outerShdw>
           </a:effectLst>
         </p:spPr>
+        <p:txBody>
+          <a:bodyPr/>
+          <a:lstStyle/>
+          <a:p>
+            <a:endParaRPr/>
+          </a:p>
+        </p:txBody>
       </p:sp>
       <p:sp>
         <p:nvSpPr>
@@ -13203,6 +13656,13 @@
             </a:outerShdw>
           </a:effectLst>
         </p:spPr>
+        <p:txBody>
+          <a:bodyPr/>
+          <a:lstStyle/>
+          <a:p>
+            <a:endParaRPr/>
+          </a:p>
+        </p:txBody>
       </p:sp>
       <p:sp>
         <p:nvSpPr>
@@ -13355,6 +13815,13 @@
             </a:outerShdw>
           </a:effectLst>
         </p:spPr>
+        <p:txBody>
+          <a:bodyPr/>
+          <a:lstStyle/>
+          <a:p>
+            <a:endParaRPr/>
+          </a:p>
+        </p:txBody>
       </p:sp>
       <p:sp>
         <p:nvSpPr>
@@ -13510,6 +13977,13 @@
           </a:gradFill>
           <a:ln/>
         </p:spPr>
+        <p:txBody>
+          <a:bodyPr/>
+          <a:lstStyle/>
+          <a:p>
+            <a:endParaRPr/>
+          </a:p>
+        </p:txBody>
       </p:sp>
       <p:sp>
         <p:nvSpPr>
@@ -13662,6 +14136,13 @@
             <a:prstDash val="solid"/>
           </a:ln>
         </p:spPr>
+        <p:txBody>
+          <a:bodyPr/>
+          <a:lstStyle/>
+          <a:p>
+            <a:endParaRPr/>
+          </a:p>
+        </p:txBody>
       </p:sp>
       <p:sp>
         <p:nvSpPr>
@@ -14047,6 +14528,13 @@
           </a:solidFill>
           <a:ln/>
         </p:spPr>
+        <p:txBody>
+          <a:bodyPr/>
+          <a:lstStyle/>
+          <a:p>
+            <a:endParaRPr/>
+          </a:p>
+        </p:txBody>
       </p:sp>
       <p:sp>
         <p:nvSpPr>
@@ -14312,6 +14800,13 @@
             <a:prstDash val="solid"/>
           </a:ln>
         </p:spPr>
+        <p:txBody>
+          <a:bodyPr/>
+          <a:lstStyle/>
+          <a:p>
+            <a:endParaRPr/>
+          </a:p>
+        </p:txBody>
       </p:sp>
       <p:graphicFrame>
         <p:nvGraphicFramePr>
@@ -14522,6 +15017,13 @@
           </a:gradFill>
           <a:ln/>
         </p:spPr>
+        <p:txBody>
+          <a:bodyPr/>
+          <a:lstStyle/>
+          <a:p>
+            <a:endParaRPr/>
+          </a:p>
+        </p:txBody>
       </p:sp>
       <p:sp>
         <p:nvSpPr>
@@ -14742,6 +15244,13 @@
           </a:solidFill>
           <a:ln/>
         </p:spPr>
+        <p:txBody>
+          <a:bodyPr/>
+          <a:lstStyle/>
+          <a:p>
+            <a:endParaRPr/>
+          </a:p>
+        </p:txBody>
       </p:sp>
       <p:sp>
         <p:nvSpPr>
@@ -15020,6 +15529,13 @@
             <a:prstDash val="solid"/>
           </a:ln>
         </p:spPr>
+        <p:txBody>
+          <a:bodyPr/>
+          <a:lstStyle/>
+          <a:p>
+            <a:endParaRPr/>
+          </a:p>
+        </p:txBody>
       </p:sp>
       <p:graphicFrame>
         <p:nvGraphicFramePr>

</xml_diff>